<commit_message>
Correct year-over-year gain endpoints to match Menchville all-responses method
Point changes were right; start/end percentages were not. Now 42→58, 60→72, 52→64.

Co-Authored-By: Claude Fable 5.1 <noreply@anthropic.com>
Claude-Session: https://claude.ai/code/session_01VxjrheVfSMgPoqBnV1z5LJ
</commit_message>
<xml_diff>
--- a/Menchville_EOC_Reading_Slide1.pptx
+++ b/Menchville_EOC_Reading_Slide1.pptx
@@ -1194,7 +1194,7 @@
                   <a:srgbClr val="10B981"/>
                 </a:solidFill>
               </a:rPr>
-              <a:t>45% → 61% (+16 pts)</a:t>
+              <a:t>42% → 58% (+16 pts)</a:t>
             </a:r>
             <a:endParaRPr lang="en-US" sz="1300" dirty="0"/>
           </a:p>
@@ -1302,7 +1302,7 @@
                   <a:srgbClr val="10B981"/>
                 </a:solidFill>
               </a:rPr>
-              <a:t>53% → 66% (+13 pts)</a:t>
+              <a:t>60% → 72% (+13 pts)</a:t>
             </a:r>
             <a:endParaRPr lang="en-US" sz="1300" dirty="0"/>
           </a:p>
@@ -1410,7 +1410,7 @@
                   <a:srgbClr val="10B981"/>
                 </a:solidFill>
               </a:rPr>
-              <a:t>50% → 62% (+12 pts)</a:t>
+              <a:t>52% → 64% (+12 pts)</a:t>
             </a:r>
             <a:endParaRPr lang="en-US" sz="1300" dirty="0"/>
           </a:p>

</xml_diff>